<commit_message>
docs: add director explanation, update deck with real model results
- docs/director_explanation.md: full educational story covering all EDA
  and modelling concepts + director presentation script with slide-by-slide
  talking points and hard-question handling
- RetentionIQ_Technical_Deck.pptx: updated all 8 slides with real numbers
  (751,956 customers, churn window 318 days, BG/NBD + GG fitted params,
  CLV distribution, AUC-ROC scores LR=0.6718 / RF=0.6814 / XGB=0.6819)
- notebooks/eda_summary_plots.png: EDA summary figure

Co-Authored-By: Claude Sonnet 4.6 <noreply@anthropic.com>
</commit_message>
<xml_diff>
--- a/RetentionIQ_Technical_Deck.pptx
+++ b/RetentionIQ_Technical_Deck.pptx
@@ -3254,7 +3254,7 @@
               </a:defRPr>
             </a:pPr>
             <a:r>
-              <a:t>March 18, 2026   |   Data source: Miracle Sheets (Shopify → Daasity → Snowflake)</a:t>
+              <a:t>March 2026   |   Data: Miracle Sheets  •  976,659 orders  •  751,956 customers  •  Jan 2024 – Mar 2026</a:t>
             </a:r>
           </a:p>
         </p:txBody>
@@ -4485,7 +4485,7 @@
               </a:defRPr>
             </a:pPr>
             <a:r>
-              <a:t>SQL against Snowflake  →  customer_features table  →  pandas DataFrame</a:t>
+              <a:t>CSV exports → pandas feature engineering → 9 RFM + behavioral features  (PoC)  |  SQL → Snowflake  (production target)</a:t>
             </a:r>
           </a:p>
         </p:txBody>
@@ -5225,7 +5225,7 @@
               </a:defRPr>
             </a:pPr>
             <a:r>
-              <a:t>Gold standard for non-contractual CLV. Models purchase frequency (Poisson/Gamma) and dropout (Beta-Geometric) separately, then combines with Gamma-Gamma for monetary value.</a:t>
+              <a:t>Gold standard for non-contractual CLV. Models purchase frequency (Poisson/Gamma) and dropout (Beta-Geometric) separately, then combines with Gamma-Gamma for monetary value.  Fitted on 751,915 customers — BG/NBD: r=0.035  α=6.76  a=0.50  b=0.21  |  Gamma-Gamma: p=4.08  q=0.43  v=3.87  →  Median 12m CLV: $14.72  |  Mean: $48.98  |  P90: $118.31  |  Max: $18,576</a:t>
             </a:r>
           </a:p>
         </p:txBody>
@@ -6429,7 +6429,8 @@
               </a:defRPr>
             </a:pPr>
             <a:r>
-              <a:t>→ Explores deep learning for CLV at ASOS. Found that probabilistic models (BG/NBD family) remain competitive with neural approaches for smaller datasets — supports our model choice for Miracle Sheets' data scale.</a:t>
+              <a:t>→ Explores deep learning for CLV at ASOS. Found that probabilistic models (BG/NBD family) remain competitive with neural approaches for smaller datasets — supports our model choice for Miracle Sheets' data scale.  
+[7] Grinsztajn, L., Oyallon, E. &amp; Varoquaux, G. (2022). "Why tree-based models still outperform deep learning on tabular data." NeurIPS 2022.  → Large-scale benchmark confirming XGBoost outperforms neural nets on structured/tabular data — direct justification for our model choice over deep learning alternatives.</a:t>
             </a:r>
           </a:p>
         </p:txBody>
@@ -6924,7 +6925,7 @@
             </a:r>
             <a:br/>
             <a:r>
-              <a:t>(SQL + Python)</a:t>
+              <a:t>(Python/pandas  PoC)</a:t>
             </a:r>
           </a:p>
         </p:txBody>
@@ -6967,11 +6968,11 @@
             </a:r>
             <a:br/>
             <a:r>
-              <a:t>table: 15+ features</a:t>
+              <a:t>9 features (PoC)</a:t>
             </a:r>
             <a:br/>
             <a:r>
-              <a:t>RFM + behavioral</a:t>
+              <a:t>RFM + behavioral(target: 15+ with discount &amp; product data)</a:t>
             </a:r>
           </a:p>
         </p:txBody>
@@ -7135,15 +7136,15 @@
               </a:defRPr>
             </a:pPr>
             <a:r>
-              <a:t>BG/NBD, XGBoost</a:t>
+              <a:t>BG/NBD + GG  (CLV)</a:t>
             </a:r>
             <a:br/>
             <a:r>
-              <a:t>SHAP, KMeans</a:t>
+              <a:t>XGBoost AUC 0.6819  ✓</a:t>
             </a:r>
             <a:br/>
             <a:r>
-              <a:t>trained on features</a:t>
+              <a:t>SHAP  |  KMeans (planned)</a:t>
             </a:r>
           </a:p>
         </p:txBody>
@@ -7604,7 +7605,7 @@
               </a:defRPr>
             </a:pPr>
             <a:r>
-              <a:t>Miracle Sheets — tens of thousands of customers, hourly data refresh via Daasity</a:t>
+              <a:t>Miracle Sheets — 751,956 customers  |  976,659 orders  |  Jan 2024 – Mar 2026  |  PoC: local CSV exports; production: hourly Shopify → Daasity → Snowflake</a:t>
             </a:r>
           </a:p>
         </p:txBody>
@@ -7682,7 +7683,7 @@
               </a:defRPr>
             </a:pPr>
             <a:r>
-              <a:t>Compute warehouse scales elastically. Feature SQL runs in seconds on current data volume. No infrastructure management needed.</a:t>
+              <a:t>PoC runs on local CSV exports — feature computation on 976k rows completes in ~60s on a laptop. Production target: Snowflake small warehouse, feature SQL in seconds, elastic auto-scaling.</a:t>
             </a:r>
           </a:p>
         </p:txBody>
@@ -8141,7 +8142,7 @@
               </a:defRPr>
             </a:pPr>
             <a:r>
-              <a:t>Full EDA on real Miracle Sheets data from Snowflake. Order volume, customer distribution, inter-purchase timing, revenue concentration, churn window analysis.</a:t>
+              <a:t>976,659 orders  |  751,956 customers  |  Jan 2024–Mar 2026  Key findings: 87.8% one-time buyers  •  Median repurchase: 59 days  •  P90 = 318 days → churn window  •  Pareto: top 20% = 40% revenue  6 figures exported to docs/figures/</a:t>
             </a:r>
           </a:p>
         </p:txBody>
@@ -8301,7 +8302,7 @@
               </a:defRPr>
             </a:pPr>
             <a:r>
-              <a:t>BG/NBD + Gamma-Gamma CLV predictions. Churn model benchmark: Logistic Regression → Random Forest → XGBoost with ROC curves. SHAP waterfall plots.</a:t>
+              <a:t>BG/NBD + Gamma-Gamma: median 12m CLV $14.72 | mean $48.98 | P90 $118.31  Churn (384,699 customers, 318-day window): LR 0.6718 → RF 0.6814 → XGBoost 0.6819 ✓  SHAP waterfall per customer — global + individual explanations</a:t>
             </a:r>
           </a:p>
         </p:txBody>
@@ -8461,7 +8462,7 @@
               </a:defRPr>
             </a:pPr>
             <a:r>
-              <a:t>Feature engineering SQL running directly against Daasity UOS in Snowflake. 15+ features across RFM, behavioral, temporal, and product affinity groups.</a:t>
+              <a:t>Feature engineering implemented in Python/pandas (PoC) — sql/features/ directory ready for production SQL.  Current: 9 RFM + behavioral features.  Next sprint: add discount_code, product_type, product_diversity_index → target 15+ features.</a:t>
             </a:r>
           </a:p>
         </p:txBody>
@@ -8621,7 +8622,7 @@
               </a:defRPr>
             </a:pPr>
             <a:r>
-              <a:t>Full project structure, .env.example, requirements, documentation. Buildable first draft — clone, set credentials, run notebooks.</a:t>
+              <a:t>github.com/giulia-bono/retentioniq  (Private)  Executed notebooks with outputs  •  6 PNG figures  •  updated deck  •  src/ scaffold  Clone → source .venv/bin/activate → jupyter notebook</a:t>
             </a:r>
           </a:p>
         </p:txBody>
@@ -8846,7 +8847,7 @@
               </a:defRPr>
             </a:pPr>
             <a:r>
-              <a:t>EDA + first model results + architecture</a:t>
+              <a:t>EDA (976k orders, 751k customers)  •  CLV &amp; churn benchmarks (XGBoost AUC 0.6819)  •  6 figures exported  •  deck updated  •  repo pushed</a:t>
             </a:r>
           </a:p>
         </p:txBody>
@@ -10224,7 +10225,7 @@
               </a:defRPr>
             </a:pPr>
             <a:r>
-              <a:t>GitHub:  github.com/[your-org]/retentioniq   ←  submit this link on a slide</a:t>
+              <a:t>GitHub:  github.com/giulia-bono/retentioniq</a:t>
             </a:r>
           </a:p>
         </p:txBody>

</xml_diff>